<commit_message>
Updated on 6th Aug 2026
</commit_message>
<xml_diff>
--- a/Ppt.pptx
+++ b/Ppt.pptx
@@ -112,23 +112,31 @@
 </p:presentation>
 </file>
 
+<file path=ppt/revisionInfo.xml><?xml version="1.0" encoding="utf-8"?>
+<p1510:revInfo xmlns:a="http://schemas.openxmlformats.org/drawingml/2006/main" xmlns:r="http://schemas.openxmlformats.org/officeDocument/2006/relationships" xmlns:p1510="http://schemas.microsoft.com/office/powerpoint/2015/10/main">
+  <p1510:revLst>
+    <p1510:client id="{E9B403ED-0CFD-4A99-99A9-C0FEBFB05FCB}" v="1" dt="2026-08-05T17:25:48.733"/>
+  </p1510:revLst>
+</p1510:revInfo>
+</file>
+
 <file path=ppt/changesInfos/changesInfo1.xml><?xml version="1.0" encoding="utf-8"?>
 <pc:chgInfo xmlns:a="http://schemas.openxmlformats.org/drawingml/2006/main" xmlns:r="http://schemas.openxmlformats.org/officeDocument/2006/relationships" xmlns:ac="http://schemas.microsoft.com/office/drawing/2013/main/command" xmlns:pc="http://schemas.microsoft.com/office/powerpoint/2013/main/command">
   <pc:docChgLst>
     <pc:chgData name="Rohan Aggarwal" userId="57e237ad-3110-4fc3-88f4-6b35faf3c368" providerId="ADAL" clId="{9FBD75EE-27C9-4EFE-B03B-639ADFCFAA04}"/>
     <pc:docChg chg="modSld">
-      <pc:chgData name="Rohan Aggarwal" userId="57e237ad-3110-4fc3-88f4-6b35faf3c368" providerId="ADAL" clId="{9FBD75EE-27C9-4EFE-B03B-639ADFCFAA04}" dt="2026-08-02T11:40:15.069" v="1" actId="6549"/>
+      <pc:chgData name="Rohan Aggarwal" userId="57e237ad-3110-4fc3-88f4-6b35faf3c368" providerId="ADAL" clId="{9FBD75EE-27C9-4EFE-B03B-639ADFCFAA04}" dt="2026-08-05T17:25:48.732" v="0"/>
       <pc:docMkLst>
         <pc:docMk/>
       </pc:docMkLst>
-      <pc:sldChg chg="modSp mod">
-        <pc:chgData name="Rohan Aggarwal" userId="57e237ad-3110-4fc3-88f4-6b35faf3c368" providerId="ADAL" clId="{9FBD75EE-27C9-4EFE-B03B-639ADFCFAA04}" dt="2026-08-02T11:40:15.069" v="1" actId="6549"/>
+      <pc:sldChg chg="modSp">
+        <pc:chgData name="Rohan Aggarwal" userId="57e237ad-3110-4fc3-88f4-6b35faf3c368" providerId="ADAL" clId="{9FBD75EE-27C9-4EFE-B03B-639ADFCFAA04}" dt="2026-08-05T17:25:48.732" v="0"/>
         <pc:sldMkLst>
           <pc:docMk/>
           <pc:sldMk cId="3605816098" sldId="256"/>
         </pc:sldMkLst>
         <pc:spChg chg="mod">
-          <ac:chgData name="Rohan Aggarwal" userId="57e237ad-3110-4fc3-88f4-6b35faf3c368" providerId="ADAL" clId="{9FBD75EE-27C9-4EFE-B03B-639ADFCFAA04}" dt="2026-08-02T11:40:15.069" v="1" actId="6549"/>
+          <ac:chgData name="Rohan Aggarwal" userId="57e237ad-3110-4fc3-88f4-6b35faf3c368" providerId="ADAL" clId="{9FBD75EE-27C9-4EFE-B03B-639ADFCFAA04}" dt="2026-08-05T17:25:48.732" v="0"/>
           <ac:spMkLst>
             <pc:docMk/>
             <pc:sldMk cId="3605816098" sldId="256"/>
@@ -290,7 +298,7 @@
           <a:p>
             <a:fld id="{C349595F-3217-40E3-A5D5-E74A35C50F4E}" type="datetimeFigureOut">
               <a:rPr lang="en-IN" smtClean="0"/>
-              <a:t>02-08-2026</a:t>
+              <a:t>05-08-2026</a:t>
             </a:fld>
             <a:endParaRPr lang="en-IN"/>
           </a:p>
@@ -490,7 +498,7 @@
           <a:p>
             <a:fld id="{C349595F-3217-40E3-A5D5-E74A35C50F4E}" type="datetimeFigureOut">
               <a:rPr lang="en-IN" smtClean="0"/>
-              <a:t>02-08-2026</a:t>
+              <a:t>05-08-2026</a:t>
             </a:fld>
             <a:endParaRPr lang="en-IN"/>
           </a:p>
@@ -700,7 +708,7 @@
           <a:p>
             <a:fld id="{C349595F-3217-40E3-A5D5-E74A35C50F4E}" type="datetimeFigureOut">
               <a:rPr lang="en-IN" smtClean="0"/>
-              <a:t>02-08-2026</a:t>
+              <a:t>05-08-2026</a:t>
             </a:fld>
             <a:endParaRPr lang="en-IN"/>
           </a:p>
@@ -900,7 +908,7 @@
           <a:p>
             <a:fld id="{C349595F-3217-40E3-A5D5-E74A35C50F4E}" type="datetimeFigureOut">
               <a:rPr lang="en-IN" smtClean="0"/>
-              <a:t>02-08-2026</a:t>
+              <a:t>05-08-2026</a:t>
             </a:fld>
             <a:endParaRPr lang="en-IN"/>
           </a:p>
@@ -1176,7 +1184,7 @@
           <a:p>
             <a:fld id="{C349595F-3217-40E3-A5D5-E74A35C50F4E}" type="datetimeFigureOut">
               <a:rPr lang="en-IN" smtClean="0"/>
-              <a:t>02-08-2026</a:t>
+              <a:t>05-08-2026</a:t>
             </a:fld>
             <a:endParaRPr lang="en-IN"/>
           </a:p>
@@ -1444,7 +1452,7 @@
           <a:p>
             <a:fld id="{C349595F-3217-40E3-A5D5-E74A35C50F4E}" type="datetimeFigureOut">
               <a:rPr lang="en-IN" smtClean="0"/>
-              <a:t>02-08-2026</a:t>
+              <a:t>05-08-2026</a:t>
             </a:fld>
             <a:endParaRPr lang="en-IN"/>
           </a:p>
@@ -1859,7 +1867,7 @@
           <a:p>
             <a:fld id="{C349595F-3217-40E3-A5D5-E74A35C50F4E}" type="datetimeFigureOut">
               <a:rPr lang="en-IN" smtClean="0"/>
-              <a:t>02-08-2026</a:t>
+              <a:t>05-08-2026</a:t>
             </a:fld>
             <a:endParaRPr lang="en-IN"/>
           </a:p>
@@ -2001,7 +2009,7 @@
           <a:p>
             <a:fld id="{C349595F-3217-40E3-A5D5-E74A35C50F4E}" type="datetimeFigureOut">
               <a:rPr lang="en-IN" smtClean="0"/>
-              <a:t>02-08-2026</a:t>
+              <a:t>05-08-2026</a:t>
             </a:fld>
             <a:endParaRPr lang="en-IN"/>
           </a:p>
@@ -2114,7 +2122,7 @@
           <a:p>
             <a:fld id="{C349595F-3217-40E3-A5D5-E74A35C50F4E}" type="datetimeFigureOut">
               <a:rPr lang="en-IN" smtClean="0"/>
-              <a:t>02-08-2026</a:t>
+              <a:t>05-08-2026</a:t>
             </a:fld>
             <a:endParaRPr lang="en-IN"/>
           </a:p>
@@ -2427,7 +2435,7 @@
           <a:p>
             <a:fld id="{C349595F-3217-40E3-A5D5-E74A35C50F4E}" type="datetimeFigureOut">
               <a:rPr lang="en-IN" smtClean="0"/>
-              <a:t>02-08-2026</a:t>
+              <a:t>05-08-2026</a:t>
             </a:fld>
             <a:endParaRPr lang="en-IN"/>
           </a:p>
@@ -2716,7 +2724,7 @@
           <a:p>
             <a:fld id="{C349595F-3217-40E3-A5D5-E74A35C50F4E}" type="datetimeFigureOut">
               <a:rPr lang="en-IN" smtClean="0"/>
-              <a:t>02-08-2026</a:t>
+              <a:t>05-08-2026</a:t>
             </a:fld>
             <a:endParaRPr lang="en-IN"/>
           </a:p>
@@ -2959,7 +2967,7 @@
           <a:p>
             <a:fld id="{C349595F-3217-40E3-A5D5-E74A35C50F4E}" type="datetimeFigureOut">
               <a:rPr lang="en-IN" smtClean="0"/>
-              <a:t>02-08-2026</a:t>
+              <a:t>05-08-2026</a:t>
             </a:fld>
             <a:endParaRPr lang="en-IN"/>
           </a:p>
@@ -3406,7 +3414,7 @@
           <a:p>
             <a:r>
               <a:rPr lang="en-US" dirty="0"/>
-              <a:t>Test</a:t>
+              <a:t>Test-6th Aug</a:t>
             </a:r>
             <a:endParaRPr lang="en-IN" dirty="0"/>
           </a:p>

</xml_diff>